<commit_message>
Auto-build: 2026-10-06 02:50 UTC
</commit_message>
<xml_diff>
--- a/reports/2026-01.pptx
+++ b/reports/2026-01.pptx
@@ -119,7 +119,7 @@
 </p:presentation>
 </file>
 
-<file path=ppt/charts/chart61.xml><?xml version="1.0" encoding="utf-8"?>
+<file path=ppt/charts/chart71.xml><?xml version="1.0" encoding="utf-8"?>
 <c:chartSpace xmlns:c="http://schemas.openxmlformats.org/drawingml/2006/chart" xmlns:a="http://schemas.openxmlformats.org/drawingml/2006/main" xmlns:r="http://schemas.openxmlformats.org/officeDocument/2006/relationships">
   <c:date1904 val="0"/>
   <c:roundedCorners val="0"/>
@@ -419,7 +419,7 @@
 </c:chartSpace>
 </file>
 
-<file path=ppt/charts/chart62.xml><?xml version="1.0" encoding="utf-8"?>
+<file path=ppt/charts/chart72.xml><?xml version="1.0" encoding="utf-8"?>
 <c:chartSpace xmlns:c="http://schemas.openxmlformats.org/drawingml/2006/chart" xmlns:a="http://schemas.openxmlformats.org/drawingml/2006/main" xmlns:r="http://schemas.openxmlformats.org/officeDocument/2006/relationships">
   <c:date1904 val="0"/>
   <c:roundedCorners val="0"/>
@@ -719,7 +719,7 @@
 </c:chartSpace>
 </file>
 
-<file path=ppt/charts/chart63.xml><?xml version="1.0" encoding="utf-8"?>
+<file path=ppt/charts/chart73.xml><?xml version="1.0" encoding="utf-8"?>
 <c:chartSpace xmlns:c="http://schemas.openxmlformats.org/drawingml/2006/chart" xmlns:a="http://schemas.openxmlformats.org/drawingml/2006/main" xmlns:r="http://schemas.openxmlformats.org/officeDocument/2006/relationships">
   <c:date1904 val="0"/>
   <c:roundedCorners val="0"/>
@@ -1019,7 +1019,7 @@
 </c:chartSpace>
 </file>
 
-<file path=ppt/charts/chart64.xml><?xml version="1.0" encoding="utf-8"?>
+<file path=ppt/charts/chart74.xml><?xml version="1.0" encoding="utf-8"?>
 <c:chartSpace xmlns:c="http://schemas.openxmlformats.org/drawingml/2006/chart" xmlns:a="http://schemas.openxmlformats.org/drawingml/2006/main" xmlns:r="http://schemas.openxmlformats.org/officeDocument/2006/relationships">
   <c:date1904 val="0"/>
   <c:roundedCorners val="0"/>
@@ -1319,7 +1319,7 @@
 </c:chartSpace>
 </file>
 
-<file path=ppt/charts/chart65.xml><?xml version="1.0" encoding="utf-8"?>
+<file path=ppt/charts/chart75.xml><?xml version="1.0" encoding="utf-8"?>
 <c:chartSpace xmlns:c="http://schemas.openxmlformats.org/drawingml/2006/chart" xmlns:a="http://schemas.openxmlformats.org/drawingml/2006/main" xmlns:r="http://schemas.openxmlformats.org/officeDocument/2006/relationships">
   <c:date1904 val="0"/>
   <c:roundedCorners val="0"/>
@@ -1619,7 +1619,7 @@
 </c:chartSpace>
 </file>
 
-<file path=ppt/charts/chart66.xml><?xml version="1.0" encoding="utf-8"?>
+<file path=ppt/charts/chart76.xml><?xml version="1.0" encoding="utf-8"?>
 <c:chartSpace xmlns:c="http://schemas.openxmlformats.org/drawingml/2006/chart" xmlns:a="http://schemas.openxmlformats.org/drawingml/2006/main" xmlns:r="http://schemas.openxmlformats.org/officeDocument/2006/relationships">
   <c:date1904 val="0"/>
   <c:roundedCorners val="0"/>
@@ -1919,7 +1919,7 @@
 </c:chartSpace>
 </file>
 
-<file path=ppt/charts/chart67.xml><?xml version="1.0" encoding="utf-8"?>
+<file path=ppt/charts/chart77.xml><?xml version="1.0" encoding="utf-8"?>
 <c:chartSpace xmlns:c="http://schemas.openxmlformats.org/drawingml/2006/chart" xmlns:a="http://schemas.openxmlformats.org/drawingml/2006/main" xmlns:r="http://schemas.openxmlformats.org/officeDocument/2006/relationships">
   <c:date1904 val="0"/>
   <c:roundedCorners val="0"/>
@@ -2219,7 +2219,7 @@
 </c:chartSpace>
 </file>
 
-<file path=ppt/charts/chart68.xml><?xml version="1.0" encoding="utf-8"?>
+<file path=ppt/charts/chart78.xml><?xml version="1.0" encoding="utf-8"?>
 <c:chartSpace xmlns:c="http://schemas.openxmlformats.org/drawingml/2006/chart" xmlns:a="http://schemas.openxmlformats.org/drawingml/2006/main" xmlns:r="http://schemas.openxmlformats.org/officeDocument/2006/relationships">
   <c:date1904 val="0"/>
   <c:roundedCorners val="0"/>
@@ -2519,7 +2519,7 @@
 </c:chartSpace>
 </file>
 
-<file path=ppt/charts/chart69.xml><?xml version="1.0" encoding="utf-8"?>
+<file path=ppt/charts/chart79.xml><?xml version="1.0" encoding="utf-8"?>
 <c:chartSpace xmlns:c="http://schemas.openxmlformats.org/drawingml/2006/chart" xmlns:a="http://schemas.openxmlformats.org/drawingml/2006/main" xmlns:r="http://schemas.openxmlformats.org/officeDocument/2006/relationships">
   <c:date1904 val="0"/>
   <c:roundedCorners val="0"/>
@@ -2819,7 +2819,7 @@
 </c:chartSpace>
 </file>
 
-<file path=ppt/charts/chart70.xml><?xml version="1.0" encoding="utf-8"?>
+<file path=ppt/charts/chart80.xml><?xml version="1.0" encoding="utf-8"?>
 <c:chartSpace xmlns:c="http://schemas.openxmlformats.org/drawingml/2006/chart" xmlns:a="http://schemas.openxmlformats.org/drawingml/2006/main" xmlns:r="http://schemas.openxmlformats.org/officeDocument/2006/relationships">
   <c:date1904 val="0"/>
   <c:roundedCorners val="0"/>
@@ -5236,7 +5236,7 @@
                 <a:ea typeface="Calibri" pitchFamily="34" charset="-122"/>
                 <a:cs typeface="Calibri" pitchFamily="34" charset="-120"/>
               </a:rPr>
-              <a:t>Prepared: September 6, 2026</a:t>
+              <a:t>Prepared: October 6, 2026</a:t>
             </a:r>
             <a:endParaRPr lang="en-US" sz="1200" dirty="0"/>
           </a:p>

</xml_diff>